<commit_message>
Update lecture decks; keep instructor reports and run logs out of the site
Commits the instructor's pending edits to eight lecture decks across Days 1-5.

reports/ (course vetting reports and session handoffs) and logs/ (Nimble run
logs) are instructor-only and discuss answer-key defects, so they are now
git-ignored alongside PREPUB_* rather than published to GitHub Pages.

Co-Authored-By: Claude Opus 5 <noreply@anthropic.com>
</commit_message>
<xml_diff>
--- a/Day1_Probability/FW536_Day1_Afternoon Distributions I.pptx
+++ b/Day1_Probability/FW536_Day1_Afternoon Distributions I.pptx
@@ -17,7 +17,7 @@
     <p:sldId id="317" r:id="rId8"/>
     <p:sldId id="331" r:id="rId9"/>
     <p:sldId id="329" r:id="rId10"/>
-    <p:sldId id="330" r:id="rId11"/>
+    <p:sldId id="339" r:id="rId11"/>
     <p:sldId id="276" r:id="rId12"/>
     <p:sldId id="279" r:id="rId13"/>
     <p:sldId id="280" r:id="rId14"/>
@@ -243,7 +243,7 @@
           <a:p>
             <a:fld id="{EF945995-FC3E-D540-94CA-CACDC057E48E}" type="datetimeFigureOut">
               <a:rPr lang="en-US" smtClean="0"/>
-              <a:t>9/18/25</a:t>
+              <a:t>9/11/26</a:t>
             </a:fld>
             <a:endParaRPr lang="en-US"/>
           </a:p>
@@ -1101,7 +1101,7 @@
               </a14:hiddenEffects>
             </a:ext>
             <a:ext uri="{FAA26D3D-D897-4be2-8F04-BA451C77F1D7}">
-              <ma14:placeholderFlag xmlns:ma14="http://schemas.microsoft.com/office/mac/drawingml/2011/main" xmlns="" val="1"/>
+              <ma14:placeholderFlag xmlns="" xmlns:ma14="http://schemas.microsoft.com/office/mac/drawingml/2011/main" val="1"/>
             </a:ext>
           </a:extLst>
         </p:spPr>
@@ -1186,7 +1186,7 @@
               </a14:hiddenEffects>
             </a:ext>
             <a:ext uri="{FAA26D3D-D897-4be2-8F04-BA451C77F1D7}">
-              <ma14:placeholderFlag xmlns:ma14="http://schemas.microsoft.com/office/mac/drawingml/2011/main" xmlns="" val="1"/>
+              <ma14:placeholderFlag xmlns="" xmlns:ma14="http://schemas.microsoft.com/office/mac/drawingml/2011/main" val="1"/>
             </a:ext>
           </a:extLst>
         </p:spPr>
@@ -1271,7 +1271,7 @@
               </a14:hiddenEffects>
             </a:ext>
             <a:ext uri="{FAA26D3D-D897-4be2-8F04-BA451C77F1D7}">
-              <ma14:placeholderFlag xmlns:ma14="http://schemas.microsoft.com/office/mac/drawingml/2011/main" xmlns="" val="1"/>
+              <ma14:placeholderFlag xmlns="" xmlns:ma14="http://schemas.microsoft.com/office/mac/drawingml/2011/main" val="1"/>
             </a:ext>
           </a:extLst>
         </p:spPr>
@@ -1423,7 +1423,7 @@
               </a14:hiddenEffects>
             </a:ext>
             <a:ext uri="{FAA26D3D-D897-4be2-8F04-BA451C77F1D7}">
-              <ma14:placeholderFlag xmlns:ma14="http://schemas.microsoft.com/office/mac/drawingml/2011/main" xmlns="" val="1"/>
+              <ma14:placeholderFlag xmlns="" xmlns:ma14="http://schemas.microsoft.com/office/mac/drawingml/2011/main" val="1"/>
             </a:ext>
           </a:extLst>
         </p:spPr>
@@ -1508,7 +1508,7 @@
               </a14:hiddenEffects>
             </a:ext>
             <a:ext uri="{FAA26D3D-D897-4be2-8F04-BA451C77F1D7}">
-              <ma14:placeholderFlag xmlns:ma14="http://schemas.microsoft.com/office/mac/drawingml/2011/main" xmlns="" val="1"/>
+              <ma14:placeholderFlag xmlns="" xmlns:ma14="http://schemas.microsoft.com/office/mac/drawingml/2011/main" val="1"/>
             </a:ext>
           </a:extLst>
         </p:spPr>
@@ -1593,7 +1593,7 @@
               </a14:hiddenEffects>
             </a:ext>
             <a:ext uri="{FAA26D3D-D897-4be2-8F04-BA451C77F1D7}">
-              <ma14:placeholderFlag xmlns:ma14="http://schemas.microsoft.com/office/mac/drawingml/2011/main" xmlns="" val="1"/>
+              <ma14:placeholderFlag xmlns="" xmlns:ma14="http://schemas.microsoft.com/office/mac/drawingml/2011/main" val="1"/>
             </a:ext>
           </a:extLst>
         </p:spPr>
@@ -1678,7 +1678,7 @@
               </a14:hiddenEffects>
             </a:ext>
             <a:ext uri="{FAA26D3D-D897-4be2-8F04-BA451C77F1D7}">
-              <ma14:placeholderFlag xmlns:ma14="http://schemas.microsoft.com/office/mac/drawingml/2011/main" xmlns="" val="1"/>
+              <ma14:placeholderFlag xmlns="" xmlns:ma14="http://schemas.microsoft.com/office/mac/drawingml/2011/main" val="1"/>
             </a:ext>
           </a:extLst>
         </p:spPr>
@@ -1763,7 +1763,7 @@
               </a14:hiddenEffects>
             </a:ext>
             <a:ext uri="{FAA26D3D-D897-4be2-8F04-BA451C77F1D7}">
-              <ma14:placeholderFlag xmlns:ma14="http://schemas.microsoft.com/office/mac/drawingml/2011/main" xmlns="" val="1"/>
+              <ma14:placeholderFlag xmlns="" xmlns:ma14="http://schemas.microsoft.com/office/mac/drawingml/2011/main" val="1"/>
             </a:ext>
           </a:extLst>
         </p:spPr>
@@ -1848,7 +1848,7 @@
               </a14:hiddenEffects>
             </a:ext>
             <a:ext uri="{FAA26D3D-D897-4be2-8F04-BA451C77F1D7}">
-              <ma14:placeholderFlag xmlns:ma14="http://schemas.microsoft.com/office/mac/drawingml/2011/main" xmlns="" val="1"/>
+              <ma14:placeholderFlag xmlns="" xmlns:ma14="http://schemas.microsoft.com/office/mac/drawingml/2011/main" val="1"/>
             </a:ext>
           </a:extLst>
         </p:spPr>
@@ -1933,7 +1933,7 @@
               </a14:hiddenEffects>
             </a:ext>
             <a:ext uri="{FAA26D3D-D897-4be2-8F04-BA451C77F1D7}">
-              <ma14:placeholderFlag xmlns:ma14="http://schemas.microsoft.com/office/mac/drawingml/2011/main" xmlns="" val="1"/>
+              <ma14:placeholderFlag xmlns="" xmlns:ma14="http://schemas.microsoft.com/office/mac/drawingml/2011/main" val="1"/>
             </a:ext>
           </a:extLst>
         </p:spPr>
@@ -2018,7 +2018,7 @@
               </a14:hiddenEffects>
             </a:ext>
             <a:ext uri="{FAA26D3D-D897-4be2-8F04-BA451C77F1D7}">
-              <ma14:placeholderFlag xmlns:ma14="http://schemas.microsoft.com/office/mac/drawingml/2011/main" xmlns="" val="1"/>
+              <ma14:placeholderFlag xmlns="" xmlns:ma14="http://schemas.microsoft.com/office/mac/drawingml/2011/main" val="1"/>
             </a:ext>
           </a:extLst>
         </p:spPr>
@@ -2103,7 +2103,7 @@
               </a14:hiddenEffects>
             </a:ext>
             <a:ext uri="{FAA26D3D-D897-4be2-8F04-BA451C77F1D7}">
-              <ma14:placeholderFlag xmlns:ma14="http://schemas.microsoft.com/office/mac/drawingml/2011/main" xmlns="" val="1"/>
+              <ma14:placeholderFlag xmlns="" xmlns:ma14="http://schemas.microsoft.com/office/mac/drawingml/2011/main" val="1"/>
             </a:ext>
           </a:extLst>
         </p:spPr>
@@ -2188,7 +2188,7 @@
               </a14:hiddenEffects>
             </a:ext>
             <a:ext uri="{FAA26D3D-D897-4be2-8F04-BA451C77F1D7}">
-              <ma14:placeholderFlag xmlns:ma14="http://schemas.microsoft.com/office/mac/drawingml/2011/main" xmlns="" val="1"/>
+              <ma14:placeholderFlag xmlns="" xmlns:ma14="http://schemas.microsoft.com/office/mac/drawingml/2011/main" val="1"/>
             </a:ext>
           </a:extLst>
         </p:spPr>
@@ -2340,7 +2340,7 @@
               </a14:hiddenEffects>
             </a:ext>
             <a:ext uri="{FAA26D3D-D897-4be2-8F04-BA451C77F1D7}">
-              <ma14:placeholderFlag xmlns:ma14="http://schemas.microsoft.com/office/mac/drawingml/2011/main" xmlns="" val="1"/>
+              <ma14:placeholderFlag xmlns="" xmlns:ma14="http://schemas.microsoft.com/office/mac/drawingml/2011/main" val="1"/>
             </a:ext>
           </a:extLst>
         </p:spPr>
@@ -2425,7 +2425,7 @@
               </a14:hiddenEffects>
             </a:ext>
             <a:ext uri="{FAA26D3D-D897-4be2-8F04-BA451C77F1D7}">
-              <ma14:placeholderFlag xmlns:ma14="http://schemas.microsoft.com/office/mac/drawingml/2011/main" xmlns="" val="1"/>
+              <ma14:placeholderFlag xmlns="" xmlns:ma14="http://schemas.microsoft.com/office/mac/drawingml/2011/main" val="1"/>
             </a:ext>
           </a:extLst>
         </p:spPr>
@@ -2510,7 +2510,7 @@
               </a14:hiddenEffects>
             </a:ext>
             <a:ext uri="{FAA26D3D-D897-4be2-8F04-BA451C77F1D7}">
-              <ma14:placeholderFlag xmlns:ma14="http://schemas.microsoft.com/office/mac/drawingml/2011/main" xmlns="" val="1"/>
+              <ma14:placeholderFlag xmlns="" xmlns:ma14="http://schemas.microsoft.com/office/mac/drawingml/2011/main" val="1"/>
             </a:ext>
           </a:extLst>
         </p:spPr>
@@ -3206,7 +3206,7 @@
               </a14:hiddenEffects>
             </a:ext>
             <a:ext uri="{FAA26D3D-D897-4be2-8F04-BA451C77F1D7}">
-              <ma14:placeholderFlag xmlns:ma14="http://schemas.microsoft.com/office/mac/drawingml/2011/main" xmlns="" val="1"/>
+              <ma14:placeholderFlag xmlns="" xmlns:ma14="http://schemas.microsoft.com/office/mac/drawingml/2011/main" val="1"/>
             </a:ext>
           </a:extLst>
         </p:spPr>
@@ -3700,7 +3700,7 @@
           <a:p>
             <a:fld id="{AFF33797-E749-0F4D-9D43-8EDD7194A7C5}" type="datetimeFigureOut">
               <a:rPr lang="en-US" smtClean="0"/>
-              <a:t>9/18/25</a:t>
+              <a:t>9/11/26</a:t>
             </a:fld>
             <a:endParaRPr lang="en-US"/>
           </a:p>
@@ -3868,7 +3868,7 @@
           <a:p>
             <a:fld id="{AFF33797-E749-0F4D-9D43-8EDD7194A7C5}" type="datetimeFigureOut">
               <a:rPr lang="en-US" smtClean="0"/>
-              <a:t>9/18/25</a:t>
+              <a:t>9/11/26</a:t>
             </a:fld>
             <a:endParaRPr lang="en-US"/>
           </a:p>
@@ -4046,7 +4046,7 @@
           <a:p>
             <a:fld id="{AFF33797-E749-0F4D-9D43-8EDD7194A7C5}" type="datetimeFigureOut">
               <a:rPr lang="en-US" smtClean="0"/>
-              <a:t>9/18/25</a:t>
+              <a:t>9/11/26</a:t>
             </a:fld>
             <a:endParaRPr lang="en-US"/>
           </a:p>
@@ -5291,7 +5291,7 @@
           <a:p>
             <a:fld id="{AFF33797-E749-0F4D-9D43-8EDD7194A7C5}" type="datetimeFigureOut">
               <a:rPr lang="en-US" smtClean="0"/>
-              <a:t>9/18/25</a:t>
+              <a:t>9/11/26</a:t>
             </a:fld>
             <a:endParaRPr lang="en-US"/>
           </a:p>
@@ -5536,7 +5536,7 @@
           <a:p>
             <a:fld id="{AFF33797-E749-0F4D-9D43-8EDD7194A7C5}" type="datetimeFigureOut">
               <a:rPr lang="en-US" smtClean="0"/>
-              <a:t>9/18/25</a:t>
+              <a:t>9/11/26</a:t>
             </a:fld>
             <a:endParaRPr lang="en-US"/>
           </a:p>
@@ -5765,7 +5765,7 @@
           <a:p>
             <a:fld id="{AFF33797-E749-0F4D-9D43-8EDD7194A7C5}" type="datetimeFigureOut">
               <a:rPr lang="en-US" smtClean="0"/>
-              <a:t>9/18/25</a:t>
+              <a:t>9/11/26</a:t>
             </a:fld>
             <a:endParaRPr lang="en-US"/>
           </a:p>
@@ -6129,7 +6129,7 @@
           <a:p>
             <a:fld id="{AFF33797-E749-0F4D-9D43-8EDD7194A7C5}" type="datetimeFigureOut">
               <a:rPr lang="en-US" smtClean="0"/>
-              <a:t>9/18/25</a:t>
+              <a:t>9/11/26</a:t>
             </a:fld>
             <a:endParaRPr lang="en-US"/>
           </a:p>
@@ -6246,7 +6246,7 @@
           <a:p>
             <a:fld id="{AFF33797-E749-0F4D-9D43-8EDD7194A7C5}" type="datetimeFigureOut">
               <a:rPr lang="en-US" smtClean="0"/>
-              <a:t>9/18/25</a:t>
+              <a:t>9/11/26</a:t>
             </a:fld>
             <a:endParaRPr lang="en-US"/>
           </a:p>
@@ -6341,7 +6341,7 @@
           <a:p>
             <a:fld id="{AFF33797-E749-0F4D-9D43-8EDD7194A7C5}" type="datetimeFigureOut">
               <a:rPr lang="en-US" smtClean="0"/>
-              <a:t>9/18/25</a:t>
+              <a:t>9/11/26</a:t>
             </a:fld>
             <a:endParaRPr lang="en-US"/>
           </a:p>
@@ -6616,7 +6616,7 @@
           <a:p>
             <a:fld id="{AFF33797-E749-0F4D-9D43-8EDD7194A7C5}" type="datetimeFigureOut">
               <a:rPr lang="en-US" smtClean="0"/>
-              <a:t>9/18/25</a:t>
+              <a:t>9/11/26</a:t>
             </a:fld>
             <a:endParaRPr lang="en-US"/>
           </a:p>
@@ -6868,7 +6868,7 @@
           <a:p>
             <a:fld id="{AFF33797-E749-0F4D-9D43-8EDD7194A7C5}" type="datetimeFigureOut">
               <a:rPr lang="en-US" smtClean="0"/>
-              <a:t>9/18/25</a:t>
+              <a:t>9/11/26</a:t>
             </a:fld>
             <a:endParaRPr lang="en-US"/>
           </a:p>
@@ -7079,7 +7079,7 @@
           <a:p>
             <a:fld id="{AFF33797-E749-0F4D-9D43-8EDD7194A7C5}" type="datetimeFigureOut">
               <a:rPr lang="en-US" smtClean="0"/>
-              <a:t>9/18/25</a:t>
+              <a:t>9/11/26</a:t>
             </a:fld>
             <a:endParaRPr lang="en-US"/>
           </a:p>
@@ -7555,39 +7555,569 @@
           <a:chExt cx="0" cy="0"/>
         </a:xfrm>
       </p:grpSpPr>
-      <p:pic>
-        <p:nvPicPr>
-          <p:cNvPr id="2" name="Picture 1"/>
-          <p:cNvPicPr>
-            <a:picLocks noChangeAspect="1"/>
-          </p:cNvPicPr>
+      <p:sp>
+        <p:nvSpPr>
+          <p:cNvPr id="2" name="TextBox 1"/>
+          <p:cNvSpPr txBox="1"/>
           <p:nvPr/>
-        </p:nvPicPr>
-        <p:blipFill rotWithShape="1">
-          <a:blip r:embed="rId2">
-            <a:extLst>
-              <a:ext uri="{28A0092B-C50C-407E-A947-70E740481C1C}">
-                <a14:useLocalDpi xmlns:a14="http://schemas.microsoft.com/office/drawing/2010/main" val="0"/>
-              </a:ext>
-            </a:extLst>
-          </a:blip>
-          <a:srcRect b="19073"/>
-          <a:stretch/>
-        </p:blipFill>
+        </p:nvSpPr>
         <p:spPr>
           <a:xfrm>
-            <a:off x="1433285" y="264885"/>
-            <a:ext cx="9533925" cy="5781352"/>
+            <a:off x="1597877" y="429477"/>
+            <a:ext cx="9204741" cy="534924"/>
           </a:xfrm>
           <a:prstGeom prst="rect">
             <a:avLst/>
           </a:prstGeom>
+          <a:noFill/>
         </p:spPr>
-      </p:pic>
+        <p:txBody>
+          <a:bodyPr wrap="square" lIns="0" tIns="0" rIns="0" bIns="0" anchor="t">
+            <a:spAutoFit/>
+          </a:bodyPr>
+          <a:lstStyle/>
+          <a:p>
+            <a:r>
+              <a:rPr sz="2800" b="0">
+                <a:solidFill>
+                  <a:srgbClr val="3333CC"/>
+                </a:solidFill>
+                <a:latin typeface="Calibri"/>
+              </a:rPr>
+              <a:t>Solution</a:t>
+            </a:r>
+          </a:p>
+        </p:txBody>
+      </p:sp>
+      <p:sp>
+        <p:nvSpPr>
+          <p:cNvPr id="3" name="TextBox 2"/>
+          <p:cNvSpPr txBox="1"/>
+          <p:nvPr/>
+        </p:nvSpPr>
+        <p:spPr>
+          <a:xfrm>
+            <a:off x="1597877" y="1238721"/>
+            <a:ext cx="9204741" cy="307777"/>
+          </a:xfrm>
+          <a:prstGeom prst="rect">
+            <a:avLst/>
+          </a:prstGeom>
+          <a:noFill/>
+        </p:spPr>
+        <p:txBody>
+          <a:bodyPr wrap="square" lIns="0" tIns="0" rIns="0" bIns="0" anchor="t">
+            <a:spAutoFit/>
+          </a:bodyPr>
+          <a:lstStyle/>
+          <a:p>
+            <a:r>
+              <a:rPr sz="2000" b="0">
+                <a:latin typeface="Calibri"/>
+              </a:rPr>
+              <a:t>1. For X ~ Bernoulli(p) we use a table. (We know E(X) = p.)</a:t>
+            </a:r>
+          </a:p>
+        </p:txBody>
+      </p:sp>
+      <p:graphicFrame>
+        <p:nvGraphicFramePr>
+          <p:cNvPr id="4" name="Table 3"/>
+          <p:cNvGraphicFramePr>
+            <a:graphicFrameLocks noGrp="1"/>
+          </p:cNvGraphicFramePr>
+          <p:nvPr/>
+        </p:nvGraphicFramePr>
+        <p:xfrm>
+          <a:off x="1597877" y="1711923"/>
+          <a:ext cx="4206240" cy="960120"/>
+        </p:xfrm>
+        <a:graphic>
+          <a:graphicData uri="http://schemas.openxmlformats.org/drawingml/2006/table">
+            <a:tbl>
+              <a:tblPr firstCol="1">
+                <a:tableStyleId>{5C22544A-7EE6-4342-B048-85BDC9FD1C3A}</a:tableStyleId>
+              </a:tblPr>
+              <a:tblGrid>
+                <a:gridCol w="1402080">
+                  <a:extLst>
+                    <a:ext uri="{9D8B030D-6E8A-4147-A177-3AD203B41FA5}">
+                      <a16:colId xmlns:a16="http://schemas.microsoft.com/office/drawing/2014/main" val="20000"/>
+                    </a:ext>
+                  </a:extLst>
+                </a:gridCol>
+                <a:gridCol w="1402080">
+                  <a:extLst>
+                    <a:ext uri="{9D8B030D-6E8A-4147-A177-3AD203B41FA5}">
+                      <a16:colId xmlns:a16="http://schemas.microsoft.com/office/drawing/2014/main" val="20001"/>
+                    </a:ext>
+                  </a:extLst>
+                </a:gridCol>
+                <a:gridCol w="1402080">
+                  <a:extLst>
+                    <a:ext uri="{9D8B030D-6E8A-4147-A177-3AD203B41FA5}">
+                      <a16:colId xmlns:a16="http://schemas.microsoft.com/office/drawing/2014/main" val="20002"/>
+                    </a:ext>
+                  </a:extLst>
+                </a:gridCol>
+              </a:tblGrid>
+              <a:tr h="317500">
+                <a:tc>
+                  <a:txBody>
+                    <a:bodyPr/>
+                    <a:lstStyle/>
+                    <a:p>
+                      <a:pPr algn="r"/>
+                      <a:r>
+                        <a:rPr sz="1500" b="1">
+                          <a:latin typeface="Cambria"/>
+                        </a:rPr>
+                        <a:t>X</a:t>
+                      </a:r>
+                    </a:p>
+                  </a:txBody>
+                  <a:tcPr/>
+                </a:tc>
+                <a:tc>
+                  <a:txBody>
+                    <a:bodyPr/>
+                    <a:lstStyle/>
+                    <a:p>
+                      <a:pPr algn="ctr"/>
+                      <a:r>
+                        <a:rPr sz="1500" b="0">
+                          <a:latin typeface="Cambria"/>
+                        </a:rPr>
+                        <a:t>0</a:t>
+                      </a:r>
+                    </a:p>
+                  </a:txBody>
+                  <a:tcPr/>
+                </a:tc>
+                <a:tc>
+                  <a:txBody>
+                    <a:bodyPr/>
+                    <a:lstStyle/>
+                    <a:p>
+                      <a:pPr algn="ctr"/>
+                      <a:r>
+                        <a:rPr sz="1500" b="0">
+                          <a:latin typeface="Cambria"/>
+                        </a:rPr>
+                        <a:t>1</a:t>
+                      </a:r>
+                    </a:p>
+                  </a:txBody>
+                  <a:tcPr/>
+                </a:tc>
+                <a:extLst>
+                  <a:ext uri="{0D108BD9-81ED-4DB2-BD59-A6C34878D82A}">
+                    <a16:rowId xmlns:a16="http://schemas.microsoft.com/office/drawing/2014/main" val="10000"/>
+                  </a:ext>
+                </a:extLst>
+              </a:tr>
+              <a:tr h="317500">
+                <a:tc>
+                  <a:txBody>
+                    <a:bodyPr/>
+                    <a:lstStyle/>
+                    <a:p>
+                      <a:pPr algn="r"/>
+                      <a:r>
+                        <a:rPr sz="1500" b="1">
+                          <a:latin typeface="Cambria"/>
+                        </a:rPr>
+                        <a:t>p(x)</a:t>
+                      </a:r>
+                    </a:p>
+                  </a:txBody>
+                  <a:tcPr/>
+                </a:tc>
+                <a:tc>
+                  <a:txBody>
+                    <a:bodyPr/>
+                    <a:lstStyle/>
+                    <a:p>
+                      <a:pPr algn="ctr"/>
+                      <a:r>
+                        <a:rPr sz="1500" b="0">
+                          <a:latin typeface="Cambria"/>
+                        </a:rPr>
+                        <a:t>1 − p</a:t>
+                      </a:r>
+                    </a:p>
+                  </a:txBody>
+                  <a:tcPr/>
+                </a:tc>
+                <a:tc>
+                  <a:txBody>
+                    <a:bodyPr/>
+                    <a:lstStyle/>
+                    <a:p>
+                      <a:pPr algn="ctr"/>
+                      <a:r>
+                        <a:rPr sz="1500" b="0">
+                          <a:latin typeface="Cambria"/>
+                        </a:rPr>
+                        <a:t>p</a:t>
+                      </a:r>
+                    </a:p>
+                  </a:txBody>
+                  <a:tcPr/>
+                </a:tc>
+                <a:extLst>
+                  <a:ext uri="{0D108BD9-81ED-4DB2-BD59-A6C34878D82A}">
+                    <a16:rowId xmlns:a16="http://schemas.microsoft.com/office/drawing/2014/main" val="10001"/>
+                  </a:ext>
+                </a:extLst>
+              </a:tr>
+              <a:tr h="317500">
+                <a:tc>
+                  <a:txBody>
+                    <a:bodyPr/>
+                    <a:lstStyle/>
+                    <a:p>
+                      <a:pPr algn="r"/>
+                      <a:r>
+                        <a:rPr sz="1500" b="1">
+                          <a:latin typeface="Cambria"/>
+                        </a:rPr>
+                        <a:t>(X − μ)</a:t>
+                      </a:r>
+                      <a:r>
+                        <a:rPr sz="1500" b="1" baseline="30000">
+                          <a:latin typeface="Cambria"/>
+                        </a:rPr>
+                        <a:t>2</a:t>
+                      </a:r>
+                    </a:p>
+                  </a:txBody>
+                  <a:tcPr/>
+                </a:tc>
+                <a:tc>
+                  <a:txBody>
+                    <a:bodyPr/>
+                    <a:lstStyle/>
+                    <a:p>
+                      <a:pPr algn="ctr"/>
+                      <a:r>
+                        <a:rPr sz="1500" b="0">
+                          <a:latin typeface="Cambria"/>
+                        </a:rPr>
+                        <a:t>p</a:t>
+                      </a:r>
+                      <a:r>
+                        <a:rPr sz="1500" b="0" baseline="30000">
+                          <a:latin typeface="Cambria"/>
+                        </a:rPr>
+                        <a:t>2</a:t>
+                      </a:r>
+                    </a:p>
+                  </a:txBody>
+                  <a:tcPr/>
+                </a:tc>
+                <a:tc>
+                  <a:txBody>
+                    <a:bodyPr/>
+                    <a:lstStyle/>
+                    <a:p>
+                      <a:pPr algn="ctr"/>
+                      <a:r>
+                        <a:rPr sz="1500" b="0">
+                          <a:latin typeface="Cambria"/>
+                        </a:rPr>
+                        <a:t>(1 − p)</a:t>
+                      </a:r>
+                      <a:r>
+                        <a:rPr sz="1500" b="0" baseline="30000">
+                          <a:latin typeface="Cambria"/>
+                        </a:rPr>
+                        <a:t>2</a:t>
+                      </a:r>
+                    </a:p>
+                  </a:txBody>
+                  <a:tcPr/>
+                </a:tc>
+                <a:extLst>
+                  <a:ext uri="{0D108BD9-81ED-4DB2-BD59-A6C34878D82A}">
+                    <a16:rowId xmlns:a16="http://schemas.microsoft.com/office/drawing/2014/main" val="10002"/>
+                  </a:ext>
+                </a:extLst>
+              </a:tr>
+            </a:tbl>
+          </a:graphicData>
+        </a:graphic>
+      </p:graphicFrame>
+      <p:sp>
+        <p:nvSpPr>
+          <p:cNvPr id="5" name="TextBox 4"/>
+          <p:cNvSpPr txBox="1"/>
+          <p:nvPr/>
+        </p:nvSpPr>
+        <p:spPr>
+          <a:xfrm>
+            <a:off x="1597877" y="2931498"/>
+            <a:ext cx="9204741" cy="307777"/>
+          </a:xfrm>
+          <a:prstGeom prst="rect">
+            <a:avLst/>
+          </a:prstGeom>
+          <a:noFill/>
+        </p:spPr>
+        <p:txBody>
+          <a:bodyPr wrap="square" lIns="0" tIns="0" rIns="0" bIns="0" anchor="t">
+            <a:spAutoFit/>
+          </a:bodyPr>
+          <a:lstStyle/>
+          <a:p>
+            <a:pPr algn="ctr"/>
+            <a:r>
+              <a:rPr sz="2000" b="0">
+                <a:latin typeface="Cambria"/>
+              </a:rPr>
+              <a:t>Var(X) = E((X − μ)</a:t>
+            </a:r>
+            <a:r>
+              <a:rPr sz="2000" b="0" baseline="30000">
+                <a:latin typeface="Cambria"/>
+              </a:rPr>
+              <a:t>2</a:t>
+            </a:r>
+            <a:r>
+              <a:rPr sz="2000" b="0">
+                <a:latin typeface="Cambria"/>
+              </a:rPr>
+              <a:t>) = (1 − p)p</a:t>
+            </a:r>
+            <a:r>
+              <a:rPr sz="2000" b="0" baseline="30000">
+                <a:latin typeface="Cambria"/>
+              </a:rPr>
+              <a:t>2</a:t>
+            </a:r>
+            <a:r>
+              <a:rPr sz="2000" b="0">
+                <a:latin typeface="Cambria"/>
+              </a:rPr>
+              <a:t> + p(1 − p)</a:t>
+            </a:r>
+            <a:r>
+              <a:rPr sz="2000" b="0" baseline="30000">
+                <a:latin typeface="Cambria"/>
+              </a:rPr>
+              <a:t>2</a:t>
+            </a:r>
+            <a:r>
+              <a:rPr sz="2000" b="0">
+                <a:latin typeface="Cambria"/>
+              </a:rPr>
+              <a:t> = p(1 − p)</a:t>
+            </a:r>
+          </a:p>
+        </p:txBody>
+      </p:sp>
+      <p:sp>
+        <p:nvSpPr>
+          <p:cNvPr id="6" name="TextBox 5"/>
+          <p:cNvSpPr txBox="1"/>
+          <p:nvPr/>
+        </p:nvSpPr>
+        <p:spPr>
+          <a:xfrm>
+            <a:off x="1597877" y="3741930"/>
+            <a:ext cx="9204741" cy="615553"/>
+          </a:xfrm>
+          <a:prstGeom prst="rect">
+            <a:avLst/>
+          </a:prstGeom>
+          <a:noFill/>
+        </p:spPr>
+        <p:txBody>
+          <a:bodyPr wrap="square" lIns="0" tIns="0" rIns="0" bIns="0" anchor="t">
+            <a:spAutoFit/>
+          </a:bodyPr>
+          <a:lstStyle/>
+          <a:p>
+            <a:r>
+              <a:rPr sz="2000" b="0" dirty="0">
+                <a:latin typeface="Calibri"/>
+              </a:rPr>
+              <a:t>2. X ~ bin(n, p) means X is the sum of n independent Bernoulli(p) random variables X</a:t>
+            </a:r>
+            <a:r>
+              <a:rPr sz="2000" b="0" baseline="-25000" dirty="0">
+                <a:latin typeface="Calibri"/>
+              </a:rPr>
+              <a:t>1</a:t>
+            </a:r>
+            <a:r>
+              <a:rPr sz="2000" b="0" dirty="0">
+                <a:latin typeface="Calibri"/>
+              </a:rPr>
+              <a:t>, X</a:t>
+            </a:r>
+            <a:r>
+              <a:rPr sz="2000" b="0" baseline="-25000" dirty="0">
+                <a:latin typeface="Calibri"/>
+              </a:rPr>
+              <a:t>2</a:t>
+            </a:r>
+            <a:r>
+              <a:rPr sz="2000" b="0" dirty="0">
+                <a:latin typeface="Calibri"/>
+              </a:rPr>
+              <a:t>, …, </a:t>
+            </a:r>
+            <a:r>
+              <a:rPr sz="2000" b="0" dirty="0" err="1">
+                <a:latin typeface="Calibri"/>
+              </a:rPr>
+              <a:t>X</a:t>
+            </a:r>
+            <a:r>
+              <a:rPr sz="2000" b="0" baseline="-25000" dirty="0" err="1">
+                <a:latin typeface="Calibri"/>
+              </a:rPr>
+              <a:t>n</a:t>
+            </a:r>
+            <a:r>
+              <a:rPr sz="2000" b="0" dirty="0">
+                <a:latin typeface="Calibri"/>
+              </a:rPr>
+              <a:t>. For independent variables, the variances add. Since Var(</a:t>
+            </a:r>
+            <a:r>
+              <a:rPr sz="2000" b="0" dirty="0" err="1">
+                <a:latin typeface="Calibri"/>
+              </a:rPr>
+              <a:t>X</a:t>
+            </a:r>
+            <a:r>
+              <a:rPr sz="2000" b="0" baseline="-25000" dirty="0" err="1">
+                <a:latin typeface="Calibri"/>
+              </a:rPr>
+              <a:t>j</a:t>
+            </a:r>
+            <a:r>
+              <a:rPr sz="2000" b="0" dirty="0">
+                <a:latin typeface="Calibri"/>
+              </a:rPr>
+              <a:t>) = p(1 − p) we have</a:t>
+            </a:r>
+          </a:p>
+        </p:txBody>
+      </p:sp>
+      <p:sp>
+        <p:nvSpPr>
+          <p:cNvPr id="7" name="TextBox 6"/>
+          <p:cNvSpPr txBox="1"/>
+          <p:nvPr/>
+        </p:nvSpPr>
+        <p:spPr>
+          <a:xfrm>
+            <a:off x="1597877" y="4560318"/>
+            <a:ext cx="9204741" cy="307777"/>
+          </a:xfrm>
+          <a:prstGeom prst="rect">
+            <a:avLst/>
+          </a:prstGeom>
+          <a:noFill/>
+        </p:spPr>
+        <p:txBody>
+          <a:bodyPr wrap="square" lIns="0" tIns="0" rIns="0" bIns="0" anchor="t">
+            <a:spAutoFit/>
+          </a:bodyPr>
+          <a:lstStyle/>
+          <a:p>
+            <a:pPr algn="ctr"/>
+            <a:r>
+              <a:rPr sz="2000" b="0" dirty="0">
+                <a:latin typeface="Cambria"/>
+              </a:rPr>
+              <a:t>Var(X) = Var(X</a:t>
+            </a:r>
+            <a:r>
+              <a:rPr sz="2000" b="0" baseline="-25000" dirty="0">
+                <a:latin typeface="Cambria"/>
+              </a:rPr>
+              <a:t>1</a:t>
+            </a:r>
+            <a:r>
+              <a:rPr sz="2000" b="0" dirty="0">
+                <a:latin typeface="Cambria"/>
+              </a:rPr>
+              <a:t>) + Var(X</a:t>
+            </a:r>
+            <a:r>
+              <a:rPr sz="2000" b="0" baseline="-25000" dirty="0">
+                <a:latin typeface="Cambria"/>
+              </a:rPr>
+              <a:t>2</a:t>
+            </a:r>
+            <a:r>
+              <a:rPr sz="2000" b="0" dirty="0">
+                <a:latin typeface="Cambria"/>
+              </a:rPr>
+              <a:t>) + … + Var(</a:t>
+            </a:r>
+            <a:r>
+              <a:rPr sz="2000" b="0" dirty="0" err="1">
+                <a:latin typeface="Cambria"/>
+              </a:rPr>
+              <a:t>X</a:t>
+            </a:r>
+            <a:r>
+              <a:rPr sz="2000" b="0" baseline="-25000" dirty="0" err="1">
+                <a:latin typeface="Cambria"/>
+              </a:rPr>
+              <a:t>n</a:t>
+            </a:r>
+            <a:r>
+              <a:rPr sz="2000" b="0" dirty="0">
+                <a:latin typeface="Cambria"/>
+              </a:rPr>
+              <a:t>) = </a:t>
+            </a:r>
+            <a:r>
+              <a:rPr sz="2000" b="0">
+                <a:latin typeface="Cambria"/>
+              </a:rPr>
+              <a:t>np(</a:t>
+            </a:r>
+            <a:r>
+              <a:rPr lang="en-US" sz="2000" b="0">
+                <a:latin typeface="Cambria"/>
+              </a:rPr>
+              <a:t>1</a:t>
+            </a:r>
+            <a:r>
+              <a:rPr sz="2000" b="0">
+                <a:latin typeface="Cambria"/>
+              </a:rPr>
+              <a:t> − </a:t>
+            </a:r>
+            <a:r>
+              <a:rPr lang="en-US" sz="2000" b="0">
+                <a:latin typeface="Cambria"/>
+              </a:rPr>
+              <a:t>p</a:t>
+            </a:r>
+            <a:r>
+              <a:rPr sz="2000" b="0">
+                <a:latin typeface="Cambria"/>
+              </a:rPr>
+              <a:t>).</a:t>
+            </a:r>
+            <a:endParaRPr sz="2000" b="0" dirty="0">
+              <a:latin typeface="Cambria"/>
+            </a:endParaRPr>
+          </a:p>
+        </p:txBody>
+      </p:sp>
     </p:spTree>
     <p:extLst>
       <p:ext uri="{BB962C8B-B14F-4D97-AF65-F5344CB8AC3E}">
-        <p14:creationId xmlns:p14="http://schemas.microsoft.com/office/powerpoint/2010/main" val="1108467006"/>
+        <p14:creationId xmlns:p14="http://schemas.microsoft.com/office/powerpoint/2010/main" val="1603591418"/>
       </p:ext>
     </p:extLst>
   </p:cSld>

</xml_diff>

<commit_message>
Harmonize site with the updated Day 1, 4 and 5 decks
Day 4's deck adds 'precision = 1/variance' to the gamma-prior slide, so the
lab's Nimble model gains a callout on the precision parameterisation and the
code comment now says precision = 1 / variance. Day 5's deck reframes the
dynamic occupancy slide as 'occupancy with a time series: model colonization
and extinction' and adds a spotted owl integrated multistate example, so the
lab's section E gains that framing and a note on how the structure scales.
Day 1 afternoon deck has no text changes. All three decks committed.

Co-Authored-By: Claude Opus 5 <noreply@anthropic.com>
</commit_message>
<xml_diff>
--- a/Day1_Probability/FW536_Day1_Afternoon Distributions I.pptx
+++ b/Day1_Probability/FW536_Day1_Afternoon Distributions I.pptx
@@ -243,7 +243,7 @@
           <a:p>
             <a:fld id="{EF945995-FC3E-D540-94CA-CACDC057E48E}" type="datetimeFigureOut">
               <a:rPr lang="en-US" smtClean="0"/>
-              <a:t>9/13/26</a:t>
+              <a:t>9/16/26</a:t>
             </a:fld>
             <a:endParaRPr lang="en-US"/>
           </a:p>
@@ -1101,7 +1101,7 @@
               </a14:hiddenEffects>
             </a:ext>
             <a:ext uri="{FAA26D3D-D897-4be2-8F04-BA451C77F1D7}">
-              <ma14:placeholderFlag xmlns:ma14="http://schemas.microsoft.com/office/mac/drawingml/2011/main" xmlns="" val="1"/>
+              <ma14:placeholderFlag xmlns="" xmlns:ma14="http://schemas.microsoft.com/office/mac/drawingml/2011/main" val="1"/>
             </a:ext>
           </a:extLst>
         </p:spPr>
@@ -1186,7 +1186,7 @@
               </a14:hiddenEffects>
             </a:ext>
             <a:ext uri="{FAA26D3D-D897-4be2-8F04-BA451C77F1D7}">
-              <ma14:placeholderFlag xmlns:ma14="http://schemas.microsoft.com/office/mac/drawingml/2011/main" xmlns="" val="1"/>
+              <ma14:placeholderFlag xmlns="" xmlns:ma14="http://schemas.microsoft.com/office/mac/drawingml/2011/main" val="1"/>
             </a:ext>
           </a:extLst>
         </p:spPr>
@@ -1271,7 +1271,7 @@
               </a14:hiddenEffects>
             </a:ext>
             <a:ext uri="{FAA26D3D-D897-4be2-8F04-BA451C77F1D7}">
-              <ma14:placeholderFlag xmlns:ma14="http://schemas.microsoft.com/office/mac/drawingml/2011/main" xmlns="" val="1"/>
+              <ma14:placeholderFlag xmlns="" xmlns:ma14="http://schemas.microsoft.com/office/mac/drawingml/2011/main" val="1"/>
             </a:ext>
           </a:extLst>
         </p:spPr>
@@ -1423,7 +1423,7 @@
               </a14:hiddenEffects>
             </a:ext>
             <a:ext uri="{FAA26D3D-D897-4be2-8F04-BA451C77F1D7}">
-              <ma14:placeholderFlag xmlns:ma14="http://schemas.microsoft.com/office/mac/drawingml/2011/main" xmlns="" val="1"/>
+              <ma14:placeholderFlag xmlns="" xmlns:ma14="http://schemas.microsoft.com/office/mac/drawingml/2011/main" val="1"/>
             </a:ext>
           </a:extLst>
         </p:spPr>
@@ -1508,7 +1508,7 @@
               </a14:hiddenEffects>
             </a:ext>
             <a:ext uri="{FAA26D3D-D897-4be2-8F04-BA451C77F1D7}">
-              <ma14:placeholderFlag xmlns:ma14="http://schemas.microsoft.com/office/mac/drawingml/2011/main" xmlns="" val="1"/>
+              <ma14:placeholderFlag xmlns="" xmlns:ma14="http://schemas.microsoft.com/office/mac/drawingml/2011/main" val="1"/>
             </a:ext>
           </a:extLst>
         </p:spPr>
@@ -1593,7 +1593,7 @@
               </a14:hiddenEffects>
             </a:ext>
             <a:ext uri="{FAA26D3D-D897-4be2-8F04-BA451C77F1D7}">
-              <ma14:placeholderFlag xmlns:ma14="http://schemas.microsoft.com/office/mac/drawingml/2011/main" xmlns="" val="1"/>
+              <ma14:placeholderFlag xmlns="" xmlns:ma14="http://schemas.microsoft.com/office/mac/drawingml/2011/main" val="1"/>
             </a:ext>
           </a:extLst>
         </p:spPr>
@@ -1678,7 +1678,7 @@
               </a14:hiddenEffects>
             </a:ext>
             <a:ext uri="{FAA26D3D-D897-4be2-8F04-BA451C77F1D7}">
-              <ma14:placeholderFlag xmlns:ma14="http://schemas.microsoft.com/office/mac/drawingml/2011/main" xmlns="" val="1"/>
+              <ma14:placeholderFlag xmlns="" xmlns:ma14="http://schemas.microsoft.com/office/mac/drawingml/2011/main" val="1"/>
             </a:ext>
           </a:extLst>
         </p:spPr>
@@ -1763,7 +1763,7 @@
               </a14:hiddenEffects>
             </a:ext>
             <a:ext uri="{FAA26D3D-D897-4be2-8F04-BA451C77F1D7}">
-              <ma14:placeholderFlag xmlns:ma14="http://schemas.microsoft.com/office/mac/drawingml/2011/main" xmlns="" val="1"/>
+              <ma14:placeholderFlag xmlns="" xmlns:ma14="http://schemas.microsoft.com/office/mac/drawingml/2011/main" val="1"/>
             </a:ext>
           </a:extLst>
         </p:spPr>
@@ -1848,7 +1848,7 @@
               </a14:hiddenEffects>
             </a:ext>
             <a:ext uri="{FAA26D3D-D897-4be2-8F04-BA451C77F1D7}">
-              <ma14:placeholderFlag xmlns:ma14="http://schemas.microsoft.com/office/mac/drawingml/2011/main" xmlns="" val="1"/>
+              <ma14:placeholderFlag xmlns="" xmlns:ma14="http://schemas.microsoft.com/office/mac/drawingml/2011/main" val="1"/>
             </a:ext>
           </a:extLst>
         </p:spPr>
@@ -1933,7 +1933,7 @@
               </a14:hiddenEffects>
             </a:ext>
             <a:ext uri="{FAA26D3D-D897-4be2-8F04-BA451C77F1D7}">
-              <ma14:placeholderFlag xmlns:ma14="http://schemas.microsoft.com/office/mac/drawingml/2011/main" xmlns="" val="1"/>
+              <ma14:placeholderFlag xmlns="" xmlns:ma14="http://schemas.microsoft.com/office/mac/drawingml/2011/main" val="1"/>
             </a:ext>
           </a:extLst>
         </p:spPr>
@@ -2018,7 +2018,7 @@
               </a14:hiddenEffects>
             </a:ext>
             <a:ext uri="{FAA26D3D-D897-4be2-8F04-BA451C77F1D7}">
-              <ma14:placeholderFlag xmlns:ma14="http://schemas.microsoft.com/office/mac/drawingml/2011/main" xmlns="" val="1"/>
+              <ma14:placeholderFlag xmlns="" xmlns:ma14="http://schemas.microsoft.com/office/mac/drawingml/2011/main" val="1"/>
             </a:ext>
           </a:extLst>
         </p:spPr>
@@ -2103,7 +2103,7 @@
               </a14:hiddenEffects>
             </a:ext>
             <a:ext uri="{FAA26D3D-D897-4be2-8F04-BA451C77F1D7}">
-              <ma14:placeholderFlag xmlns:ma14="http://schemas.microsoft.com/office/mac/drawingml/2011/main" xmlns="" val="1"/>
+              <ma14:placeholderFlag xmlns="" xmlns:ma14="http://schemas.microsoft.com/office/mac/drawingml/2011/main" val="1"/>
             </a:ext>
           </a:extLst>
         </p:spPr>
@@ -2188,7 +2188,7 @@
               </a14:hiddenEffects>
             </a:ext>
             <a:ext uri="{FAA26D3D-D897-4be2-8F04-BA451C77F1D7}">
-              <ma14:placeholderFlag xmlns:ma14="http://schemas.microsoft.com/office/mac/drawingml/2011/main" xmlns="" val="1"/>
+              <ma14:placeholderFlag xmlns="" xmlns:ma14="http://schemas.microsoft.com/office/mac/drawingml/2011/main" val="1"/>
             </a:ext>
           </a:extLst>
         </p:spPr>
@@ -2340,7 +2340,7 @@
               </a14:hiddenEffects>
             </a:ext>
             <a:ext uri="{FAA26D3D-D897-4be2-8F04-BA451C77F1D7}">
-              <ma14:placeholderFlag xmlns:ma14="http://schemas.microsoft.com/office/mac/drawingml/2011/main" xmlns="" val="1"/>
+              <ma14:placeholderFlag xmlns="" xmlns:ma14="http://schemas.microsoft.com/office/mac/drawingml/2011/main" val="1"/>
             </a:ext>
           </a:extLst>
         </p:spPr>
@@ -2425,7 +2425,7 @@
               </a14:hiddenEffects>
             </a:ext>
             <a:ext uri="{FAA26D3D-D897-4be2-8F04-BA451C77F1D7}">
-              <ma14:placeholderFlag xmlns:ma14="http://schemas.microsoft.com/office/mac/drawingml/2011/main" xmlns="" val="1"/>
+              <ma14:placeholderFlag xmlns="" xmlns:ma14="http://schemas.microsoft.com/office/mac/drawingml/2011/main" val="1"/>
             </a:ext>
           </a:extLst>
         </p:spPr>
@@ -2510,7 +2510,7 @@
               </a14:hiddenEffects>
             </a:ext>
             <a:ext uri="{FAA26D3D-D897-4be2-8F04-BA451C77F1D7}">
-              <ma14:placeholderFlag xmlns:ma14="http://schemas.microsoft.com/office/mac/drawingml/2011/main" xmlns="" val="1"/>
+              <ma14:placeholderFlag xmlns="" xmlns:ma14="http://schemas.microsoft.com/office/mac/drawingml/2011/main" val="1"/>
             </a:ext>
           </a:extLst>
         </p:spPr>
@@ -3206,7 +3206,7 @@
               </a14:hiddenEffects>
             </a:ext>
             <a:ext uri="{FAA26D3D-D897-4be2-8F04-BA451C77F1D7}">
-              <ma14:placeholderFlag xmlns:ma14="http://schemas.microsoft.com/office/mac/drawingml/2011/main" xmlns="" val="1"/>
+              <ma14:placeholderFlag xmlns="" xmlns:ma14="http://schemas.microsoft.com/office/mac/drawingml/2011/main" val="1"/>
             </a:ext>
           </a:extLst>
         </p:spPr>
@@ -3700,7 +3700,7 @@
           <a:p>
             <a:fld id="{AFF33797-E749-0F4D-9D43-8EDD7194A7C5}" type="datetimeFigureOut">
               <a:rPr lang="en-US" smtClean="0"/>
-              <a:t>9/13/26</a:t>
+              <a:t>9/16/26</a:t>
             </a:fld>
             <a:endParaRPr lang="en-US"/>
           </a:p>
@@ -3868,7 +3868,7 @@
           <a:p>
             <a:fld id="{AFF33797-E749-0F4D-9D43-8EDD7194A7C5}" type="datetimeFigureOut">
               <a:rPr lang="en-US" smtClean="0"/>
-              <a:t>9/13/26</a:t>
+              <a:t>9/16/26</a:t>
             </a:fld>
             <a:endParaRPr lang="en-US"/>
           </a:p>
@@ -4046,7 +4046,7 @@
           <a:p>
             <a:fld id="{AFF33797-E749-0F4D-9D43-8EDD7194A7C5}" type="datetimeFigureOut">
               <a:rPr lang="en-US" smtClean="0"/>
-              <a:t>9/13/26</a:t>
+              <a:t>9/16/26</a:t>
             </a:fld>
             <a:endParaRPr lang="en-US"/>
           </a:p>
@@ -5291,7 +5291,7 @@
           <a:p>
             <a:fld id="{AFF33797-E749-0F4D-9D43-8EDD7194A7C5}" type="datetimeFigureOut">
               <a:rPr lang="en-US" smtClean="0"/>
-              <a:t>9/13/26</a:t>
+              <a:t>9/16/26</a:t>
             </a:fld>
             <a:endParaRPr lang="en-US"/>
           </a:p>
@@ -5536,7 +5536,7 @@
           <a:p>
             <a:fld id="{AFF33797-E749-0F4D-9D43-8EDD7194A7C5}" type="datetimeFigureOut">
               <a:rPr lang="en-US" smtClean="0"/>
-              <a:t>9/13/26</a:t>
+              <a:t>9/16/26</a:t>
             </a:fld>
             <a:endParaRPr lang="en-US"/>
           </a:p>
@@ -5765,7 +5765,7 @@
           <a:p>
             <a:fld id="{AFF33797-E749-0F4D-9D43-8EDD7194A7C5}" type="datetimeFigureOut">
               <a:rPr lang="en-US" smtClean="0"/>
-              <a:t>9/13/26</a:t>
+              <a:t>9/16/26</a:t>
             </a:fld>
             <a:endParaRPr lang="en-US"/>
           </a:p>
@@ -6129,7 +6129,7 @@
           <a:p>
             <a:fld id="{AFF33797-E749-0F4D-9D43-8EDD7194A7C5}" type="datetimeFigureOut">
               <a:rPr lang="en-US" smtClean="0"/>
-              <a:t>9/13/26</a:t>
+              <a:t>9/16/26</a:t>
             </a:fld>
             <a:endParaRPr lang="en-US"/>
           </a:p>
@@ -6246,7 +6246,7 @@
           <a:p>
             <a:fld id="{AFF33797-E749-0F4D-9D43-8EDD7194A7C5}" type="datetimeFigureOut">
               <a:rPr lang="en-US" smtClean="0"/>
-              <a:t>9/13/26</a:t>
+              <a:t>9/16/26</a:t>
             </a:fld>
             <a:endParaRPr lang="en-US"/>
           </a:p>
@@ -6341,7 +6341,7 @@
           <a:p>
             <a:fld id="{AFF33797-E749-0F4D-9D43-8EDD7194A7C5}" type="datetimeFigureOut">
               <a:rPr lang="en-US" smtClean="0"/>
-              <a:t>9/13/26</a:t>
+              <a:t>9/16/26</a:t>
             </a:fld>
             <a:endParaRPr lang="en-US"/>
           </a:p>
@@ -6616,7 +6616,7 @@
           <a:p>
             <a:fld id="{AFF33797-E749-0F4D-9D43-8EDD7194A7C5}" type="datetimeFigureOut">
               <a:rPr lang="en-US" smtClean="0"/>
-              <a:t>9/13/26</a:t>
+              <a:t>9/16/26</a:t>
             </a:fld>
             <a:endParaRPr lang="en-US"/>
           </a:p>
@@ -6868,7 +6868,7 @@
           <a:p>
             <a:fld id="{AFF33797-E749-0F4D-9D43-8EDD7194A7C5}" type="datetimeFigureOut">
               <a:rPr lang="en-US" smtClean="0"/>
-              <a:t>9/13/26</a:t>
+              <a:t>9/16/26</a:t>
             </a:fld>
             <a:endParaRPr lang="en-US"/>
           </a:p>
@@ -7079,7 +7079,7 @@
           <a:p>
             <a:fld id="{AFF33797-E749-0F4D-9D43-8EDD7194A7C5}" type="datetimeFigureOut">
               <a:rPr lang="en-US" smtClean="0"/>
-              <a:t>9/13/26</a:t>
+              <a:t>9/16/26</a:t>
             </a:fld>
             <a:endParaRPr lang="en-US"/>
           </a:p>

</xml_diff>